<commit_message>
docs: fix broken images on the PROVEN LIVE slide
The duplicated slide kept the source slide's r:embed relationship IDs, but the
image relationships weren't copied to the new slide part -> PowerPoint showed
"picture can't be displayed" placeholders for the green circles. Rebuilt the
slide copying the four image parts and remapping r:embed/r:link to the new rIds.
</commit_message>
<xml_diff>
--- a/docs/Safety_and_Trust_Engine.pptx
+++ b/docs/Safety_and_Trust_Engine.pptx
@@ -11019,7 +11019,7 @@
           <p:nvPr/>
         </p:nvPicPr>
         <p:blipFill>
-          <a:blip r:embed="rId1"/>
+          <a:blip r:embed="rId2"/>
           <a:stretch>
             <a:fillRect/>
           </a:stretch>
@@ -11183,7 +11183,7 @@
           <p:nvPr/>
         </p:nvPicPr>
         <p:blipFill>
-          <a:blip r:embed="rId2"/>
+          <a:blip r:embed="rId3"/>
           <a:stretch>
             <a:fillRect/>
           </a:stretch>
@@ -11459,7 +11459,7 @@
           <p:nvPr/>
         </p:nvPicPr>
         <p:blipFill>
-          <a:blip r:embed="rId3"/>
+          <a:blip r:embed="rId4"/>
           <a:stretch>
             <a:fillRect/>
           </a:stretch>
@@ -11735,7 +11735,7 @@
           <p:nvPr/>
         </p:nvPicPr>
         <p:blipFill>
-          <a:blip r:embed="rId4"/>
+          <a:blip r:embed="rId5"/>
           <a:stretch>
             <a:fillRect/>
           </a:stretch>

</xml_diff>